<commit_message>
feat(slide3): Perfect Algo-Sapiens style Technical Approach diagram
- Rebuilds Slide 3 with exact Zone 1-4 + Implementation Process layout
- Zone 1: Real circular AI-generated investigating officer avatar + 6 external API pills (1930, EVM RPC, TRON, Bitcoin, Cross-Chain, FIU-IND)
- Zone 2: 8 UI module cards with color-coded badges (DASH, DAG, PATH, TX, AML, VASP, LAW, AUDIT)
- Zone 3: 8 backend microservice cards with colored tags (GW, ROUTE, LRU, BFS, BRG, AML, LEGAL, KYC)
- Zone 4: AI brain illustration + 5 intelligence engine cards + DB cylinder illustration
- Implementation Process: 6 numbered milestone circles on vertical red spine with detailed cards
- Bottom ribbon: 10 real brand logos (Next.js, TypeScript, React, Tailwind, Node.js, Python, PostgreSQL, Redis, Bitcoin, Ethereum)
- Inter-zone HTTP/REST + Data Exchange arrows
- Exported to PDF and PNG preview
</commit_message>
<xml_diff>
--- a/sih ppt/SIH2026-IDEA-Presentation-Format.pptx
+++ b/sih ppt/SIH2026-IDEA-Presentation-Format.pptx
@@ -6689,70 +6689,22 @@
       </p:pic>
       <p:pic>
         <p:nvPicPr>
-          <p:cNvPr id="17410" name="Picture 17409" descr="technical_architecture_flowchart.png"/>
+          <p:cNvPr id="17410" name="Picture 17409" descr="technical_approach_algo_sapiens_style.png"/>
           <p:cNvPicPr>
             <a:picLocks noChangeAspect="1"/>
           </p:cNvPicPr>
           <p:nvPr/>
         </p:nvPicPr>
         <p:blipFill>
-          <a:blip r:embed="rId4"/>
+          <a:blip r:embed="rId7"/>
           <a:stretch>
             <a:fillRect/>
           </a:stretch>
         </p:blipFill>
         <p:spPr>
           <a:xfrm>
-            <a:off x="365760" y="1051560"/>
-            <a:ext cx="11457432" cy="5166360"/>
-          </a:xfrm>
-          <a:prstGeom prst="rect">
-            <a:avLst/>
-          </a:prstGeom>
-        </p:spPr>
-      </p:pic>
-      <p:pic>
-        <p:nvPicPr>
-          <p:cNvPr id="17411" name="Picture 17410" descr="technical_architecture_flowchart.png"/>
-          <p:cNvPicPr>
-            <a:picLocks noChangeAspect="1"/>
-          </p:cNvPicPr>
-          <p:nvPr/>
-        </p:nvPicPr>
-        <p:blipFill>
-          <a:blip r:embed="rId5"/>
-          <a:stretch>
-            <a:fillRect/>
-          </a:stretch>
-        </p:blipFill>
-        <p:spPr>
-          <a:xfrm>
-            <a:off x="365760" y="1051560"/>
-            <a:ext cx="11457432" cy="5166360"/>
-          </a:xfrm>
-          <a:prstGeom prst="rect">
-            <a:avLst/>
-          </a:prstGeom>
-        </p:spPr>
-      </p:pic>
-      <p:pic>
-        <p:nvPicPr>
-          <p:cNvPr id="17412" name="Picture 17411" descr="technical_architecture_flowchart.png"/>
-          <p:cNvPicPr>
-            <a:picLocks noChangeAspect="1"/>
-          </p:cNvPicPr>
-          <p:nvPr/>
-        </p:nvPicPr>
-        <p:blipFill>
-          <a:blip r:embed="rId6"/>
-          <a:stretch>
-            <a:fillRect/>
-          </a:stretch>
-        </p:blipFill>
-        <p:spPr>
-          <a:xfrm>
-            <a:off x="365760" y="1051560"/>
-            <a:ext cx="11457432" cy="5166360"/>
+            <a:off x="292608" y="1005840"/>
+            <a:ext cx="11603736" cy="5532120"/>
           </a:xfrm>
           <a:prstGeom prst="rect">
             <a:avLst/>

</xml_diff>

<commit_message>
fix(slide3): push diagram up to clear bottom blue footer bar
</commit_message>
<xml_diff>
--- a/sih ppt/SIH2026-IDEA-Presentation-Format.pptx
+++ b/sih ppt/SIH2026-IDEA-Presentation-Format.pptx
@@ -6689,7 +6689,7 @@
       </p:pic>
       <p:pic>
         <p:nvPicPr>
-          <p:cNvPr id="17410" name="Picture 17409" descr="technical_approach_algo_sapiens_style.png"/>
+          <p:cNvPr id="17410" name="Picture 17409" descr="image.png"/>
           <p:cNvPicPr>
             <a:picLocks noChangeAspect="1"/>
           </p:cNvPicPr>
@@ -6703,8 +6703,8 @@
         </p:blipFill>
         <p:spPr>
           <a:xfrm>
-            <a:off x="292608" y="1005840"/>
-            <a:ext cx="11603736" cy="5532120"/>
+            <a:off x="292608" y="804672"/>
+            <a:ext cx="11603736" cy="5257800"/>
           </a:xfrm>
           <a:prstGeom prst="rect">
             <a:avLst/>

</xml_diff>

<commit_message>
fix(slide3): precise position - clear header (1.21in top) and footer (6.87in bottom)
</commit_message>
<xml_diff>
--- a/sih ppt/SIH2026-IDEA-Presentation-Format.pptx
+++ b/sih ppt/SIH2026-IDEA-Presentation-Format.pptx
@@ -6703,8 +6703,8 @@
         </p:blipFill>
         <p:spPr>
           <a:xfrm>
-            <a:off x="292608" y="804672"/>
-            <a:ext cx="11603736" cy="5257800"/>
+            <a:off x="292608" y="1106424"/>
+            <a:ext cx="11603736" cy="5175504"/>
           </a:xfrm>
           <a:prstGeom prst="rect">
             <a:avLst/>

</xml_diff>

<commit_message>
feat(slide3): Add HD crisp decluttered architecture diagram for Google Slides
- Decluttered content following winning Algo Sapiens model (5 clear modules per zone)
- Bold, large, high-contrast text avoiding downscaling blur
- Generated right-sized HD image (1560x705) and compact image (1248x564)
- Symmetrical margins clearing header and blue footer
- Updated PPTX presentations and exported PDF and slide preview PNG
</commit_message>
<xml_diff>
--- a/sih ppt/SIH2026-IDEA-Presentation-Format.pptx
+++ b/sih ppt/SIH2026-IDEA-Presentation-Format.pptx
@@ -15099,22 +15099,22 @@
       </p:pic>
       <p:pic>
         <p:nvPicPr>
-          <p:cNvPr id="119" name="Picture 118" descr="technical_approach_final.png"/>
+          <p:cNvPr id="119" name="Picture 118" descr="technical_approach_hd.png"/>
           <p:cNvPicPr>
             <a:picLocks noChangeAspect="1"/>
           </p:cNvPicPr>
           <p:nvPr/>
         </p:nvPicPr>
         <p:blipFill>
-          <a:blip r:embed="rId4"/>
+          <a:blip r:embed="rId5"/>
           <a:stretch>
             <a:fillRect/>
           </a:stretch>
         </p:blipFill>
         <p:spPr>
           <a:xfrm>
-            <a:off x="384048" y="1188720"/>
-            <a:ext cx="11420856" cy="5029200"/>
+            <a:off x="420624" y="1207008"/>
+            <a:ext cx="11338560" cy="5010912"/>
           </a:xfrm>
           <a:prstGeom prst="rect">
             <a:avLst/>

</xml_diff>

<commit_message>
feat(slide3): 300 DPI Ultra-HD architecture diagram with zero text overflow
- Rendered master 300 DPI Ultra-HD diagram (5142 x 2277 px) for 5x zoom clarity
- Widened Zone 4 and constrained text bounds so App Database & Storage bullets stay comfortably inside borders
- Zero overlapping lines or border cutoffs across all zones
- Updated PPTX presentations and re-exported PDF and Slide 3 preview
</commit_message>
<xml_diff>
--- a/sih ppt/SIH2026-IDEA-Presentation-Format.pptx
+++ b/sih ppt/SIH2026-IDEA-Presentation-Format.pptx
@@ -15099,22 +15099,22 @@
       </p:pic>
       <p:pic>
         <p:nvPicPr>
-          <p:cNvPr id="119" name="Picture 118" descr="technical_approach_hd.png"/>
+          <p:cNvPr id="119" name="Picture 118" descr="technical_approach_ultra_hd.png"/>
           <p:cNvPicPr>
             <a:picLocks noChangeAspect="1"/>
           </p:cNvPicPr>
           <p:nvPr/>
         </p:nvPicPr>
         <p:blipFill>
-          <a:blip r:embed="rId5"/>
+          <a:blip r:embed="rId6"/>
           <a:stretch>
             <a:fillRect/>
           </a:stretch>
         </p:blipFill>
         <p:spPr>
           <a:xfrm>
-            <a:off x="420624" y="1207008"/>
-            <a:ext cx="11338560" cy="5010912"/>
+            <a:off x="402336" y="1188720"/>
+            <a:ext cx="11384280" cy="5038344"/>
           </a:xfrm>
           <a:prstGeom prst="rect">
             <a:avLst/>

</xml_diff>

<commit_message>
feat(presentation): bright Ultra-HD diagrams + arch flowchart on Slide 3 | AEGIS-TRACE SIH26183
</commit_message>
<xml_diff>
--- a/sih ppt/SIH2026-IDEA-Presentation-Format.pptx
+++ b/sih ppt/SIH2026-IDEA-Presentation-Format.pptx
@@ -15106,15 +15106,15 @@
           <p:nvPr/>
         </p:nvPicPr>
         <p:blipFill>
-          <a:blip r:embed="rId6"/>
+          <a:blip r:embed="rId7"/>
           <a:stretch>
             <a:fillRect/>
           </a:stretch>
         </p:blipFill>
         <p:spPr>
           <a:xfrm>
-            <a:off x="402336" y="1188720"/>
-            <a:ext cx="11384280" cy="5038344"/>
+            <a:off x="384048" y="1207008"/>
+            <a:ext cx="11420856" cy="5029200"/>
           </a:xfrm>
           <a:prstGeom prst="rect">
             <a:avLst/>

</xml_diff>

<commit_message>
docs: finalize SIH 2026 6-slide winning pitch deck and export crystal-clear PDF
</commit_message>
<xml_diff>
--- a/sih ppt/SIH2026-IDEA-Presentation-Format.pptx
+++ b/sih ppt/SIH2026-IDEA-Presentation-Format.pptx
@@ -14,7 +14,6 @@
     <p:sldId id="259" r:id="rId9"/>
     <p:sldId id="260" r:id="rId10"/>
     <p:sldId id="261" r:id="rId11"/>
-    <p:sldId id="262" r:id="rId12"/>
   </p:sldIdLst>
   <p:sldSz cy="6858000" cx="12192000"/>
   <p:notesSz cx="6858000" cy="9144000"/>
@@ -2317,187 +2316,6 @@
       <p:sp>
         <p:nvSpPr>
           <p:cNvPr id="146" name="Google Shape;146;p6:notes"/>
-          <p:cNvSpPr txBox="1"/>
-          <p:nvPr>
-            <p:ph idx="12" type="sldNum"/>
-          </p:nvPr>
-        </p:nvSpPr>
-        <p:spPr>
-          <a:xfrm>
-            <a:off x="3884613" y="8685213"/>
-            <a:ext cx="2971800" cy="457200"/>
-          </a:xfrm>
-          <a:prstGeom prst="rect">
-            <a:avLst/>
-          </a:prstGeom>
-          <a:noFill/>
-          <a:ln>
-            <a:noFill/>
-          </a:ln>
-        </p:spPr>
-        <p:txBody>
-          <a:bodyPr anchorCtr="0" anchor="b" bIns="45700" lIns="91425" spcFirstLastPara="1" rIns="91425" wrap="square" tIns="45700">
-            <a:noAutofit/>
-          </a:bodyPr>
-          <a:lstStyle/>
-          <a:p>
-            <a:pPr indent="0" lvl="0" marL="0" marR="0" rtl="0" algn="r">
-              <a:lnSpc>
-                <a:spcPct val="100000"/>
-              </a:lnSpc>
-              <a:spcBef>
-                <a:spcPts val="0"/>
-              </a:spcBef>
-              <a:spcAft>
-                <a:spcPts val="0"/>
-              </a:spcAft>
-              <a:buClr>
-                <a:srgbClr val="000000"/>
-              </a:buClr>
-              <a:buSzPts val="1200"/>
-              <a:buFont typeface="Calibri"/>
-              <a:buNone/>
-            </a:pPr>
-            <a:fld id="{00000000-1234-1234-1234-123412341234}" type="slidenum">
-              <a:rPr b="0" i="0" lang="en-US" sz="1200" u="none" cap="none" strike="noStrike">
-                <a:solidFill>
-                  <a:srgbClr val="000000"/>
-                </a:solidFill>
-                <a:latin typeface="Calibri"/>
-                <a:ea typeface="Calibri"/>
-                <a:cs typeface="Calibri"/>
-                <a:sym typeface="Calibri"/>
-              </a:rPr>
-              <a:t>‹#›</a:t>
-            </a:fld>
-            <a:endParaRPr b="0" i="0" sz="1200" u="none" cap="none" strike="noStrike">
-              <a:solidFill>
-                <a:srgbClr val="000000"/>
-              </a:solidFill>
-              <a:latin typeface="Calibri"/>
-              <a:ea typeface="Calibri"/>
-              <a:cs typeface="Calibri"/>
-              <a:sym typeface="Calibri"/>
-            </a:endParaRPr>
-          </a:p>
-        </p:txBody>
-      </p:sp>
-    </p:spTree>
-  </p:cSld>
-  <p:clrMapOvr>
-    <a:masterClrMapping/>
-  </p:clrMapOvr>
-</p:notes>
-</file>
-
-<file path=ppt/notesSlides/notesSlide7.xml><?xml version="1.0" encoding="utf-8"?>
-<p:notes xmlns:a="http://schemas.openxmlformats.org/drawingml/2006/main" xmlns:r="http://schemas.openxmlformats.org/officeDocument/2006/relationships" xmlns:mc="http://schemas.openxmlformats.org/markup-compatibility/2006" xmlns:mv="urn:schemas-microsoft-com:mac:vml" xmlns:p="http://schemas.openxmlformats.org/presentationml/2006/main" xmlns:c="http://schemas.openxmlformats.org/drawingml/2006/chart" xmlns:dgm="http://schemas.openxmlformats.org/drawingml/2006/diagram" xmlns:o="urn:schemas-microsoft-com:office:office" xmlns:v="urn:schemas-microsoft-com:vml" xmlns:pvml="urn:schemas-microsoft-com:office:powerpoint" xmlns:com="http://schemas.openxmlformats.org/drawingml/2006/compatibility" xmlns:p14="http://schemas.microsoft.com/office/powerpoint/2010/main" xmlns:p15="http://schemas.microsoft.com/office/powerpoint/2012/main" xmlns:ahyp="http://schemas.microsoft.com/office/drawing/2018/hyperlinkcolor" showMasterPhAnim="0" showMasterSp="0">
-  <p:cSld>
-    <p:spTree>
-      <p:nvGrpSpPr>
-        <p:cNvPr id="155" name="Shape 155"/>
-        <p:cNvGrpSpPr/>
-        <p:nvPr/>
-      </p:nvGrpSpPr>
-      <p:grpSpPr>
-        <a:xfrm>
-          <a:off x="0" y="0"/>
-          <a:ext cx="0" cy="0"/>
-          <a:chOff x="0" y="0"/>
-          <a:chExt cx="0" cy="0"/>
-        </a:xfrm>
-      </p:grpSpPr>
-      <p:sp>
-        <p:nvSpPr>
-          <p:cNvPr id="156" name="Google Shape;156;p7:notes"/>
-          <p:cNvSpPr/>
-          <p:nvPr>
-            <p:ph idx="2" type="sldImg"/>
-          </p:nvPr>
-        </p:nvSpPr>
-        <p:spPr>
-          <a:xfrm>
-            <a:off x="381000" y="685800"/>
-            <a:ext cx="6096000" cy="3429000"/>
-          </a:xfrm>
-          <a:custGeom>
-            <a:rect b="b" l="l" r="r" t="t"/>
-            <a:pathLst>
-              <a:path extrusionOk="0" h="120000" w="120000">
-                <a:moveTo>
-                  <a:pt x="0" y="0"/>
-                </a:moveTo>
-                <a:lnTo>
-                  <a:pt x="120000" y="0"/>
-                </a:lnTo>
-                <a:lnTo>
-                  <a:pt x="120000" y="120000"/>
-                </a:lnTo>
-                <a:lnTo>
-                  <a:pt x="0" y="120000"/>
-                </a:lnTo>
-                <a:close/>
-              </a:path>
-            </a:pathLst>
-          </a:custGeom>
-          <a:noFill/>
-          <a:ln cap="flat" cmpd="sng" w="9525">
-            <a:solidFill>
-              <a:srgbClr val="000000"/>
-            </a:solidFill>
-            <a:prstDash val="solid"/>
-            <a:miter lim="8000"/>
-            <a:headEnd len="sm" w="sm" type="none"/>
-            <a:tailEnd len="sm" w="sm" type="none"/>
-          </a:ln>
-        </p:spPr>
-      </p:sp>
-      <p:sp>
-        <p:nvSpPr>
-          <p:cNvPr id="157" name="Google Shape;157;p7:notes"/>
-          <p:cNvSpPr txBox="1"/>
-          <p:nvPr>
-            <p:ph idx="1" type="body"/>
-          </p:nvPr>
-        </p:nvSpPr>
-        <p:spPr>
-          <a:xfrm>
-            <a:off x="685800" y="4343400"/>
-            <a:ext cx="5486400" cy="4114800"/>
-          </a:xfrm>
-          <a:prstGeom prst="rect">
-            <a:avLst/>
-          </a:prstGeom>
-          <a:noFill/>
-          <a:ln>
-            <a:noFill/>
-          </a:ln>
-        </p:spPr>
-        <p:txBody>
-          <a:bodyPr anchorCtr="0" anchor="t" bIns="45700" lIns="91425" spcFirstLastPara="1" rIns="91425" wrap="square" tIns="45700">
-            <a:noAutofit/>
-          </a:bodyPr>
-          <a:lstStyle/>
-          <a:p>
-            <a:pPr indent="0" lvl="0" marL="0" rtl="0" algn="l">
-              <a:spcBef>
-                <a:spcPts val="0"/>
-              </a:spcBef>
-              <a:spcAft>
-                <a:spcPts val="0"/>
-              </a:spcAft>
-              <a:buNone/>
-            </a:pPr>
-            <a:r>
-              <a:t/>
-            </a:r>
-            <a:endParaRPr/>
-          </a:p>
-        </p:txBody>
-      </p:sp>
-      <p:sp>
-        <p:nvSpPr>
-          <p:cNvPr id="158" name="Google Shape;158;p7:notes"/>
           <p:cNvSpPr txBox="1"/>
           <p:nvPr>
             <p:ph idx="12" type="sldNum"/>
@@ -13976,15 +13794,30 @@
           <a:p>
             <a:pPr indent="0" lvl="0" marL="0" marR="0" rtl="0" algn="l">
               <a:spcBef>
-                <a:spcPts val="0"/>
-              </a:spcBef>
-              <a:spcAft>
-                <a:spcPts val="0"/>
+                <a:spcPts val="400"/>
+              </a:spcBef>
+              <a:spcAft>
+                <a:spcPts val="800"/>
               </a:spcAft>
               <a:buNone/>
             </a:pPr>
             <a:r>
-              <a:t/>
+              <a:rPr sz="1750" b="1">
+                <a:solidFill>
+                  <a:srgbClr val="0F172A"/>
+                </a:solidFill>
+                <a:latin typeface="Arial"/>
+              </a:rPr>
+              <a:t>• Problem Statement ID – </a:t>
+            </a:r>
+            <a:r>
+              <a:rPr sz="1750" b="1">
+                <a:solidFill>
+                  <a:srgbClr val="2563EB"/>
+                </a:solidFill>
+                <a:latin typeface="Arial"/>
+              </a:rPr>
+              <a:t>SIH26183</a:t>
             </a:r>
             <a:endParaRPr sz="1800">
               <a:solidFill>
@@ -13997,204 +13830,144 @@
             </a:endParaRPr>
           </a:p>
           <a:p>
-            <a:pPr indent="-285750" lvl="0" marL="285750" marR="0" rtl="0" algn="just">
-              <a:lnSpc>
-                <a:spcPct val="200000"/>
-              </a:lnSpc>
-              <a:spcBef>
-                <a:spcPts val="0"/>
-              </a:spcBef>
-              <a:spcAft>
-                <a:spcPts val="0"/>
-              </a:spcAft>
-              <a:buClr>
-                <a:schemeClr val="dk1"/>
-              </a:buClr>
-              <a:buSzPts val="2400"/>
-              <a:buFont typeface="Arial"/>
-              <a:buChar char="•"/>
+            <a:pPr>
+              <a:spcBef>
+                <a:spcPts val="400"/>
+              </a:spcBef>
+              <a:spcAft>
+                <a:spcPts val="800"/>
+              </a:spcAft>
             </a:pPr>
             <a:r>
-              <a:rPr b="1" lang="en-US" sz="2400">
-                <a:solidFill>
-                  <a:schemeClr val="dk1"/>
+              <a:rPr sz="1750" b="1">
+                <a:solidFill>
+                  <a:srgbClr val="0F172A"/>
                 </a:solidFill>
                 <a:latin typeface="Arial"/>
-                <a:ea typeface="Arial"/>
-                <a:cs typeface="Arial"/>
-                <a:sym typeface="Arial"/>
               </a:rPr>
-              <a:t>Problem Statement ID –SIH26183</a:t>
+              <a:t>• Problem Statement Title – </a:t>
             </a:r>
-            <a:endParaRPr/>
+            <a:r>
+              <a:rPr sz="1750" b="1">
+                <a:solidFill>
+                  <a:srgbClr val="334155"/>
+                </a:solidFill>
+                <a:latin typeface="Arial"/>
+              </a:rPr>
+              <a:t>Real-Time Identification of Fraud-Linked Cryptocurrency Exchanges &amp; Automated Attribution of Unknown Wallets</a:t>
+            </a:r>
           </a:p>
           <a:p>
-            <a:pPr indent="-285750" lvl="0" marL="285750" marR="0" rtl="0" algn="just">
-              <a:lnSpc>
-                <a:spcPct val="200000"/>
-              </a:lnSpc>
-              <a:spcBef>
-                <a:spcPts val="0"/>
-              </a:spcBef>
-              <a:spcAft>
-                <a:spcPts val="0"/>
-              </a:spcAft>
-              <a:buClr>
-                <a:schemeClr val="dk1"/>
-              </a:buClr>
-              <a:buSzPts val="2400"/>
-              <a:buFont typeface="Arial"/>
-              <a:buChar char="•"/>
+            <a:pPr>
+              <a:spcBef>
+                <a:spcPts val="400"/>
+              </a:spcBef>
+              <a:spcAft>
+                <a:spcPts val="800"/>
+              </a:spcAft>
             </a:pPr>
             <a:r>
-              <a:rPr b="1" lang="en-US" sz="2400">
-                <a:solidFill>
-                  <a:schemeClr val="dk1"/>
+              <a:rPr sz="1750" b="1">
+                <a:solidFill>
+                  <a:srgbClr val="0F172A"/>
                 </a:solidFill>
                 <a:latin typeface="Arial"/>
-                <a:ea typeface="Arial"/>
-                <a:cs typeface="Arial"/>
-                <a:sym typeface="Arial"/>
               </a:rPr>
-              <a:t>Problem Statement Title-</a:t>
+              <a:t>• Theme – </a:t>
             </a:r>
-            <a:endParaRPr/>
+            <a:r>
+              <a:rPr sz="1750" b="1">
+                <a:solidFill>
+                  <a:srgbClr val="334155"/>
+                </a:solidFill>
+                <a:latin typeface="Arial"/>
+              </a:rPr>
+              <a:t>Blockchain &amp; Cybersecurity / Smart Automation</a:t>
+            </a:r>
           </a:p>
           <a:p>
-            <a:pPr indent="-285750" lvl="0" marL="285750" marR="0" rtl="0" algn="just">
-              <a:lnSpc>
-                <a:spcPct val="200000"/>
-              </a:lnSpc>
-              <a:spcBef>
-                <a:spcPts val="0"/>
-              </a:spcBef>
-              <a:spcAft>
-                <a:spcPts val="0"/>
-              </a:spcAft>
-              <a:buClr>
-                <a:schemeClr val="dk1"/>
-              </a:buClr>
-              <a:buSzPts val="2400"/>
-              <a:buFont typeface="Arial"/>
-              <a:buChar char="•"/>
+            <a:pPr>
+              <a:spcBef>
+                <a:spcPts val="400"/>
+              </a:spcBef>
+              <a:spcAft>
+                <a:spcPts val="800"/>
+              </a:spcAft>
             </a:pPr>
             <a:r>
-              <a:rPr b="1" lang="en-US" sz="2400">
-                <a:solidFill>
-                  <a:schemeClr val="dk1"/>
+              <a:rPr sz="1750" b="1">
+                <a:solidFill>
+                  <a:srgbClr val="0F172A"/>
                 </a:solidFill>
                 <a:latin typeface="Arial"/>
-                <a:ea typeface="Arial"/>
-                <a:cs typeface="Arial"/>
-                <a:sym typeface="Arial"/>
               </a:rPr>
-              <a:t>Theme-</a:t>
+              <a:t>• PS Category – </a:t>
             </a:r>
-            <a:endParaRPr/>
+            <a:r>
+              <a:rPr sz="1750" b="1">
+                <a:solidFill>
+                  <a:srgbClr val="334155"/>
+                </a:solidFill>
+                <a:latin typeface="Arial"/>
+              </a:rPr>
+              <a:t>Software</a:t>
+            </a:r>
           </a:p>
           <a:p>
-            <a:pPr indent="-285750" lvl="0" marL="285750" marR="0" rtl="0" algn="just">
-              <a:lnSpc>
-                <a:spcPct val="200000"/>
-              </a:lnSpc>
-              <a:spcBef>
-                <a:spcPts val="0"/>
-              </a:spcBef>
-              <a:spcAft>
-                <a:spcPts val="0"/>
-              </a:spcAft>
-              <a:buClr>
-                <a:schemeClr val="dk1"/>
-              </a:buClr>
-              <a:buSzPts val="2400"/>
-              <a:buFont typeface="Arial"/>
-              <a:buChar char="•"/>
+            <a:pPr>
+              <a:spcBef>
+                <a:spcPts val="400"/>
+              </a:spcBef>
+              <a:spcAft>
+                <a:spcPts val="800"/>
+              </a:spcAft>
             </a:pPr>
             <a:r>
-              <a:rPr b="1" lang="en-US" sz="2400">
-                <a:solidFill>
-                  <a:schemeClr val="dk1"/>
+              <a:rPr sz="1750" b="1">
+                <a:solidFill>
+                  <a:srgbClr val="0F172A"/>
                 </a:solidFill>
                 <a:latin typeface="Arial"/>
-                <a:ea typeface="Arial"/>
-                <a:cs typeface="Arial"/>
-                <a:sym typeface="Arial"/>
               </a:rPr>
-              <a:t>PS Category- Software/Hardware</a:t>
+              <a:t>• Team ID – </a:t>
             </a:r>
-            <a:endParaRPr/>
+            <a:r>
+              <a:rPr sz="1750" b="1">
+                <a:solidFill>
+                  <a:srgbClr val="334155"/>
+                </a:solidFill>
+                <a:latin typeface="Arial"/>
+              </a:rPr>
+              <a:t>SIH26183-T101</a:t>
+            </a:r>
           </a:p>
           <a:p>
-            <a:pPr indent="-285750" lvl="0" marL="285750" marR="0" rtl="0" algn="just">
-              <a:lnSpc>
-                <a:spcPct val="200000"/>
-              </a:lnSpc>
-              <a:spcBef>
-                <a:spcPts val="0"/>
-              </a:spcBef>
-              <a:spcAft>
-                <a:spcPts val="0"/>
-              </a:spcAft>
-              <a:buClr>
-                <a:schemeClr val="dk1"/>
-              </a:buClr>
-              <a:buSzPts val="2400"/>
-              <a:buFont typeface="Arial"/>
-              <a:buChar char="•"/>
+            <a:pPr>
+              <a:spcBef>
+                <a:spcPts val="400"/>
+              </a:spcBef>
+              <a:spcAft>
+                <a:spcPts val="800"/>
+              </a:spcAft>
             </a:pPr>
             <a:r>
-              <a:rPr b="1" lang="en-US" sz="2400">
-                <a:solidFill>
-                  <a:schemeClr val="dk1"/>
+              <a:rPr sz="1750" b="1">
+                <a:solidFill>
+                  <a:srgbClr val="0F172A"/>
                 </a:solidFill>
                 <a:latin typeface="Arial"/>
-                <a:ea typeface="Arial"/>
-                <a:cs typeface="Arial"/>
-                <a:sym typeface="Arial"/>
               </a:rPr>
-              <a:t>Team ID-</a:t>
+              <a:t>• Team Name (Registered on portal) – </a:t>
             </a:r>
-            <a:endParaRPr/>
-          </a:p>
-          <a:p>
-            <a:pPr indent="-285750" lvl="0" marL="285750" marR="0" rtl="0" algn="just">
-              <a:lnSpc>
-                <a:spcPct val="200000"/>
-              </a:lnSpc>
-              <a:spcBef>
-                <a:spcPts val="0"/>
-              </a:spcBef>
-              <a:spcAft>
-                <a:spcPts val="0"/>
-              </a:spcAft>
-              <a:buClr>
-                <a:schemeClr val="dk1"/>
-              </a:buClr>
-              <a:buSzPts val="2400"/>
-              <a:buFont typeface="Arial"/>
-              <a:buChar char="•"/>
-            </a:pPr>
             <a:r>
-              <a:rPr b="1" lang="en-US" sz="2400">
-                <a:solidFill>
-                  <a:schemeClr val="dk1"/>
+              <a:rPr sz="1750" b="1">
+                <a:solidFill>
+                  <a:srgbClr val="0E7490"/>
                 </a:solidFill>
                 <a:latin typeface="Arial"/>
-                <a:ea typeface="Arial"/>
-                <a:cs typeface="Arial"/>
-                <a:sym typeface="Arial"/>
               </a:rPr>
-              <a:t>Team Name (Registered on portal)</a:t>
+              <a:t>Aegis trace</a:t>
             </a:r>
-            <a:endParaRPr b="1" sz="2400">
-              <a:solidFill>
-                <a:schemeClr val="dk1"/>
-              </a:solidFill>
-              <a:latin typeface="Arial"/>
-              <a:ea typeface="Arial"/>
-              <a:cs typeface="Arial"/>
-              <a:sym typeface="Arial"/>
-            </a:endParaRPr>
           </a:p>
         </p:txBody>
       </p:sp>
@@ -14367,212 +14140,6 @@
       </p:sp>
       <p:sp>
         <p:nvSpPr>
-          <p:cNvPr id="102" name="Google Shape;102;p14"/>
-          <p:cNvSpPr txBox="1"/>
-          <p:nvPr/>
-        </p:nvSpPr>
-        <p:spPr>
-          <a:xfrm>
-            <a:off x="-1" y="2064921"/>
-            <a:ext cx="12191999" cy="2492990"/>
-          </a:xfrm>
-          <a:prstGeom prst="rect">
-            <a:avLst/>
-          </a:prstGeom>
-          <a:noFill/>
-          <a:ln>
-            <a:noFill/>
-          </a:ln>
-        </p:spPr>
-        <p:txBody>
-          <a:bodyPr anchorCtr="0" anchor="t" bIns="45700" lIns="91425" spcFirstLastPara="1" rIns="91425" wrap="square" tIns="45700">
-            <a:spAutoFit/>
-          </a:bodyPr>
-          <a:lstStyle/>
-          <a:p>
-            <a:pPr indent="-342900" lvl="0" marL="342900" marR="0" rtl="0" algn="l">
-              <a:spcBef>
-                <a:spcPts val="0"/>
-              </a:spcBef>
-              <a:spcAft>
-                <a:spcPts val="0"/>
-              </a:spcAft>
-              <a:buClr>
-                <a:schemeClr val="dk2"/>
-              </a:buClr>
-              <a:buSzPts val="3200"/>
-              <a:buFont typeface="Noto Sans Symbols"/>
-              <a:buChar char="❖"/>
-            </a:pPr>
-            <a:r>
-              <a:rPr b="1" lang="en-US" sz="3200" u="sng">
-                <a:solidFill>
-                  <a:schemeClr val="dk2"/>
-                </a:solidFill>
-                <a:latin typeface="Arial"/>
-                <a:ea typeface="Arial"/>
-                <a:cs typeface="Arial"/>
-                <a:sym typeface="Arial"/>
-              </a:rPr>
-              <a:t>Proposed Solution (Describe your Idea/Solution/Prototype)</a:t>
-            </a:r>
-            <a:endParaRPr sz="3200" u="sng">
-              <a:solidFill>
-                <a:schemeClr val="dk2"/>
-              </a:solidFill>
-              <a:latin typeface="Arial"/>
-              <a:ea typeface="Arial"/>
-              <a:cs typeface="Arial"/>
-              <a:sym typeface="Arial"/>
-            </a:endParaRPr>
-          </a:p>
-          <a:p>
-            <a:pPr indent="-215900" lvl="0" marL="342900" marR="0" rtl="0" algn="l">
-              <a:spcBef>
-                <a:spcPts val="0"/>
-              </a:spcBef>
-              <a:spcAft>
-                <a:spcPts val="0"/>
-              </a:spcAft>
-              <a:buClr>
-                <a:schemeClr val="dk1"/>
-              </a:buClr>
-              <a:buSzPts val="2000"/>
-              <a:buFont typeface="Arial"/>
-              <a:buNone/>
-            </a:pPr>
-            <a:r>
-              <a:t/>
-            </a:r>
-            <a:endParaRPr sz="2000" u="sng">
-              <a:solidFill>
-                <a:schemeClr val="dk2"/>
-              </a:solidFill>
-              <a:latin typeface="Arial"/>
-              <a:ea typeface="Arial"/>
-              <a:cs typeface="Arial"/>
-              <a:sym typeface="Arial"/>
-            </a:endParaRPr>
-          </a:p>
-          <a:p>
-            <a:pPr indent="-215900" lvl="0" marL="342900" marR="0" rtl="0" algn="l">
-              <a:spcBef>
-                <a:spcPts val="0"/>
-              </a:spcBef>
-              <a:spcAft>
-                <a:spcPts val="0"/>
-              </a:spcAft>
-              <a:buClr>
-                <a:schemeClr val="dk1"/>
-              </a:buClr>
-              <a:buSzPts val="2000"/>
-              <a:buFont typeface="Arial"/>
-              <a:buNone/>
-            </a:pPr>
-            <a:r>
-              <a:t/>
-            </a:r>
-            <a:endParaRPr sz="2000" u="sng">
-              <a:solidFill>
-                <a:schemeClr val="dk2"/>
-              </a:solidFill>
-              <a:latin typeface="Arial"/>
-              <a:ea typeface="Arial"/>
-              <a:cs typeface="Arial"/>
-              <a:sym typeface="Arial"/>
-            </a:endParaRPr>
-          </a:p>
-          <a:p>
-            <a:pPr indent="-342900" lvl="0" marL="342900" marR="0" rtl="0" algn="just">
-              <a:spcBef>
-                <a:spcPts val="0"/>
-              </a:spcBef>
-              <a:spcAft>
-                <a:spcPts val="0"/>
-              </a:spcAft>
-              <a:buClr>
-                <a:schemeClr val="dk1"/>
-              </a:buClr>
-              <a:buSzPts val="2800"/>
-              <a:buFont typeface="Arial"/>
-              <a:buChar char="•"/>
-            </a:pPr>
-            <a:r>
-              <a:rPr lang="en-US" sz="2800">
-                <a:solidFill>
-                  <a:schemeClr val="dk1"/>
-                </a:solidFill>
-                <a:latin typeface="Arial"/>
-                <a:ea typeface="Arial"/>
-                <a:cs typeface="Arial"/>
-                <a:sym typeface="Arial"/>
-              </a:rPr>
-              <a:t>Detailed explanation of the proposed solution</a:t>
-            </a:r>
-            <a:endParaRPr/>
-          </a:p>
-          <a:p>
-            <a:pPr indent="-342900" lvl="0" marL="342900" marR="0" rtl="0" algn="just">
-              <a:spcBef>
-                <a:spcPts val="0"/>
-              </a:spcBef>
-              <a:spcAft>
-                <a:spcPts val="0"/>
-              </a:spcAft>
-              <a:buClr>
-                <a:schemeClr val="dk1"/>
-              </a:buClr>
-              <a:buSzPts val="2800"/>
-              <a:buFont typeface="Arial"/>
-              <a:buChar char="•"/>
-            </a:pPr>
-            <a:r>
-              <a:rPr lang="en-US" sz="2800">
-                <a:solidFill>
-                  <a:schemeClr val="dk1"/>
-                </a:solidFill>
-                <a:latin typeface="Arial"/>
-                <a:ea typeface="Arial"/>
-                <a:cs typeface="Arial"/>
-                <a:sym typeface="Arial"/>
-              </a:rPr>
-              <a:t> How it addresses the problem</a:t>
-            </a:r>
-            <a:endParaRPr/>
-          </a:p>
-          <a:p>
-            <a:pPr indent="-342900" lvl="0" marL="342900" marR="0" rtl="0" algn="just">
-              <a:spcBef>
-                <a:spcPts val="0"/>
-              </a:spcBef>
-              <a:spcAft>
-                <a:spcPts val="0"/>
-              </a:spcAft>
-              <a:buClr>
-                <a:schemeClr val="dk1"/>
-              </a:buClr>
-              <a:buSzPts val="2800"/>
-              <a:buFont typeface="Arial"/>
-              <a:buChar char="•"/>
-            </a:pPr>
-            <a:r>
-              <a:rPr lang="en-US" sz="2800">
-                <a:solidFill>
-                  <a:schemeClr val="dk1"/>
-                </a:solidFill>
-                <a:latin typeface="Arial"/>
-                <a:ea typeface="Arial"/>
-                <a:cs typeface="Arial"/>
-                <a:sym typeface="Arial"/>
-              </a:rPr>
-              <a:t>Innovation and uniqueness of the solution </a:t>
-            </a:r>
-            <a:endParaRPr/>
-          </a:p>
-        </p:txBody>
-      </p:sp>
-      <p:sp>
-        <p:nvSpPr>
           <p:cNvPr id="103" name="Google Shape;103;p14"/>
           <p:cNvSpPr txBox="1"/>
           <p:nvPr>
@@ -14718,7 +14285,7 @@
               <a:buNone/>
             </a:pPr>
             <a:r>
-              <a:rPr lang="en-US" sz="1800">
+              <a:rPr lang="en-US" sz="1800" b="1">
                 <a:solidFill>
                   <a:schemeClr val="dk1"/>
                 </a:solidFill>
@@ -14727,7 +14294,7 @@
                 <a:cs typeface="Calibri"/>
                 <a:sym typeface="Calibri"/>
               </a:rPr>
-              <a:t>Your Team Name</a:t>
+              <a:t>AEGIS-TRACE</a:t>
             </a:r>
             <a:endParaRPr sz="1800">
               <a:solidFill>
@@ -14766,6 +14333,30 @@
           <a:ln>
             <a:noFill/>
           </a:ln>
+        </p:spPr>
+      </p:pic>
+      <p:pic>
+        <p:nvPicPr>
+          <p:cNvPr id="107" name="Picture 106" descr="slide_2_proposed_solution.png"/>
+          <p:cNvPicPr>
+            <a:picLocks noChangeAspect="1"/>
+          </p:cNvPicPr>
+          <p:nvPr/>
+        </p:nvPicPr>
+        <p:blipFill>
+          <a:blip r:embed="rId4"/>
+          <a:stretch>
+            <a:fillRect/>
+          </a:stretch>
+        </p:blipFill>
+        <p:spPr>
+          <a:xfrm>
+            <a:off x="384048" y="1207008"/>
+            <a:ext cx="11420856" cy="5029200"/>
+          </a:xfrm>
+          <a:prstGeom prst="rect">
+            <a:avLst/>
+          </a:prstGeom>
         </p:spPr>
       </p:pic>
     </p:spTree>
@@ -15047,7 +14638,7 @@
               <a:buNone/>
             </a:pPr>
             <a:r>
-              <a:rPr lang="en-US" sz="1800">
+              <a:rPr lang="en-US" sz="1800" b="1">
                 <a:solidFill>
                   <a:schemeClr val="dk1"/>
                 </a:solidFill>
@@ -15056,7 +14647,7 @@
                 <a:cs typeface="Calibri"/>
                 <a:sym typeface="Calibri"/>
               </a:rPr>
-              <a:t>Your Team Name</a:t>
+              <a:t>AEGIS-TRACE</a:t>
             </a:r>
             <a:endParaRPr sz="1800">
               <a:solidFill>
@@ -15099,14 +14690,14 @@
       </p:pic>
       <p:pic>
         <p:nvPicPr>
-          <p:cNvPr id="119" name="Picture 118" descr="technical_approach_ultra_hd.png"/>
+          <p:cNvPr id="119" name="Picture 118" descr="slide_3_technical_approach_crisp.png"/>
           <p:cNvPicPr>
             <a:picLocks noChangeAspect="1"/>
           </p:cNvPicPr>
           <p:nvPr/>
         </p:nvPicPr>
         <p:blipFill>
-          <a:blip r:embed="rId7"/>
+          <a:blip r:embed="rId4"/>
           <a:stretch>
             <a:fillRect/>
           </a:stretch>
@@ -15263,156 +14854,6 @@
       </p:sp>
       <p:sp>
         <p:nvSpPr>
-          <p:cNvPr id="126" name="Google Shape;126;p16"/>
-          <p:cNvSpPr txBox="1"/>
-          <p:nvPr/>
-        </p:nvSpPr>
-        <p:spPr>
-          <a:xfrm>
-            <a:off x="609600" y="2533653"/>
-            <a:ext cx="9385300" cy="1384995"/>
-          </a:xfrm>
-          <a:prstGeom prst="rect">
-            <a:avLst/>
-          </a:prstGeom>
-          <a:noFill/>
-          <a:ln>
-            <a:noFill/>
-          </a:ln>
-        </p:spPr>
-        <p:txBody>
-          <a:bodyPr anchorCtr="0" anchor="t" bIns="45700" lIns="91425" spcFirstLastPara="1" rIns="91425" wrap="square" tIns="45700">
-            <a:spAutoFit/>
-          </a:bodyPr>
-          <a:lstStyle/>
-          <a:p>
-            <a:pPr indent="-342900" lvl="0" marL="342900" marR="0" rtl="0" algn="just">
-              <a:lnSpc>
-                <a:spcPct val="100000"/>
-              </a:lnSpc>
-              <a:spcBef>
-                <a:spcPts val="0"/>
-              </a:spcBef>
-              <a:spcAft>
-                <a:spcPts val="0"/>
-              </a:spcAft>
-              <a:buClr>
-                <a:srgbClr val="000000"/>
-              </a:buClr>
-              <a:buSzPts val="2800"/>
-              <a:buFont typeface="Arial"/>
-              <a:buChar char="•"/>
-            </a:pPr>
-            <a:r>
-              <a:rPr lang="en-US" sz="2800">
-                <a:solidFill>
-                  <a:srgbClr val="000000"/>
-                </a:solidFill>
-                <a:latin typeface="Arial"/>
-                <a:ea typeface="Arial"/>
-                <a:cs typeface="Arial"/>
-                <a:sym typeface="Arial"/>
-              </a:rPr>
-              <a:t>Analysis of the feasibility of the idea</a:t>
-            </a:r>
-            <a:endParaRPr b="0" i="0" sz="2800" u="none" cap="none" strike="noStrike">
-              <a:solidFill>
-                <a:srgbClr val="000000"/>
-              </a:solidFill>
-              <a:latin typeface="Arial"/>
-              <a:ea typeface="Arial"/>
-              <a:cs typeface="Arial"/>
-              <a:sym typeface="Arial"/>
-            </a:endParaRPr>
-          </a:p>
-          <a:p>
-            <a:pPr indent="-342900" lvl="0" marL="342900" marR="0" rtl="0" algn="just">
-              <a:lnSpc>
-                <a:spcPct val="100000"/>
-              </a:lnSpc>
-              <a:spcBef>
-                <a:spcPts val="0"/>
-              </a:spcBef>
-              <a:spcAft>
-                <a:spcPts val="0"/>
-              </a:spcAft>
-              <a:buClr>
-                <a:srgbClr val="000000"/>
-              </a:buClr>
-              <a:buSzPts val="2800"/>
-              <a:buFont typeface="Arial"/>
-              <a:buChar char="•"/>
-            </a:pPr>
-            <a:r>
-              <a:rPr lang="en-US" sz="2800">
-                <a:solidFill>
-                  <a:srgbClr val="000000"/>
-                </a:solidFill>
-                <a:latin typeface="Arial"/>
-                <a:ea typeface="Arial"/>
-                <a:cs typeface="Arial"/>
-                <a:sym typeface="Arial"/>
-              </a:rPr>
-              <a:t>Potential challenges and risks</a:t>
-            </a:r>
-            <a:endParaRPr/>
-          </a:p>
-          <a:p>
-            <a:pPr indent="-342900" lvl="0" marL="342900" marR="0" rtl="0" algn="just">
-              <a:lnSpc>
-                <a:spcPct val="100000"/>
-              </a:lnSpc>
-              <a:spcBef>
-                <a:spcPts val="0"/>
-              </a:spcBef>
-              <a:spcAft>
-                <a:spcPts val="0"/>
-              </a:spcAft>
-              <a:buClr>
-                <a:srgbClr val="000000"/>
-              </a:buClr>
-              <a:buSzPts val="2800"/>
-              <a:buFont typeface="Arial"/>
-              <a:buChar char="•"/>
-            </a:pPr>
-            <a:r>
-              <a:rPr b="0" i="0" lang="en-US" sz="2800" u="none" cap="none" strike="noStrike">
-                <a:solidFill>
-                  <a:srgbClr val="000000"/>
-                </a:solidFill>
-                <a:latin typeface="Arial"/>
-                <a:ea typeface="Arial"/>
-                <a:cs typeface="Arial"/>
-                <a:sym typeface="Arial"/>
-              </a:rPr>
-              <a:t>Strategies</a:t>
-            </a:r>
-            <a:r>
-              <a:rPr b="0" i="0" lang="en-US" sz="2800" u="none" cap="none" strike="noStrike">
-                <a:solidFill>
-                  <a:srgbClr val="000000"/>
-                </a:solidFill>
-                <a:latin typeface="Arial"/>
-                <a:ea typeface="Arial"/>
-                <a:cs typeface="Arial"/>
-                <a:sym typeface="Arial"/>
-              </a:rPr>
-              <a:t> for overcoming these challenges</a:t>
-            </a:r>
-            <a:endParaRPr b="0" i="0" sz="2800" u="none" cap="none" strike="noStrike">
-              <a:solidFill>
-                <a:srgbClr val="000000"/>
-              </a:solidFill>
-              <a:latin typeface="Arial"/>
-              <a:ea typeface="Arial"/>
-              <a:cs typeface="Arial"/>
-              <a:sym typeface="Arial"/>
-            </a:endParaRPr>
-          </a:p>
-        </p:txBody>
-      </p:sp>
-      <p:sp>
-        <p:nvSpPr>
           <p:cNvPr id="127" name="Google Shape;127;p16"/>
           <p:cNvSpPr txBox="1"/>
           <p:nvPr>
@@ -15590,7 +15031,7 @@
               <a:buNone/>
             </a:pPr>
             <a:r>
-              <a:rPr lang="en-US" sz="1800">
+              <a:rPr lang="en-US" sz="1800" b="1">
                 <a:solidFill>
                   <a:schemeClr val="dk1"/>
                 </a:solidFill>
@@ -15599,7 +15040,7 @@
                 <a:cs typeface="Calibri"/>
                 <a:sym typeface="Calibri"/>
               </a:rPr>
-              <a:t>Your Team Name</a:t>
+              <a:t>AEGIS-TRACE</a:t>
             </a:r>
             <a:endParaRPr sz="1800">
               <a:solidFill>
@@ -15638,6 +15079,30 @@
           <a:ln>
             <a:noFill/>
           </a:ln>
+        </p:spPr>
+      </p:pic>
+      <p:pic>
+        <p:nvPicPr>
+          <p:cNvPr id="131" name="Picture 130" descr="slide_4_feasibility_viability.png"/>
+          <p:cNvPicPr>
+            <a:picLocks noChangeAspect="1"/>
+          </p:cNvPicPr>
+          <p:nvPr/>
+        </p:nvPicPr>
+        <p:blipFill>
+          <a:blip r:embed="rId4"/>
+          <a:stretch>
+            <a:fillRect/>
+          </a:stretch>
+        </p:blipFill>
+        <p:spPr>
+          <a:xfrm>
+            <a:off x="384048" y="1207008"/>
+            <a:ext cx="11420856" cy="5029200"/>
+          </a:xfrm>
+          <a:prstGeom prst="rect">
+            <a:avLst/>
+          </a:prstGeom>
         </p:spPr>
       </p:pic>
     </p:spTree>
@@ -15782,96 +15247,6 @@
       </p:sp>
       <p:sp>
         <p:nvSpPr>
-          <p:cNvPr id="138" name="Google Shape;138;p17"/>
-          <p:cNvSpPr txBox="1"/>
-          <p:nvPr/>
-        </p:nvSpPr>
-        <p:spPr>
-          <a:xfrm>
-            <a:off x="609600" y="2533653"/>
-            <a:ext cx="9385300" cy="1384995"/>
-          </a:xfrm>
-          <a:prstGeom prst="rect">
-            <a:avLst/>
-          </a:prstGeom>
-          <a:noFill/>
-          <a:ln>
-            <a:noFill/>
-          </a:ln>
-        </p:spPr>
-        <p:txBody>
-          <a:bodyPr anchorCtr="0" anchor="t" bIns="45700" lIns="91425" spcFirstLastPara="1" rIns="91425" wrap="square" tIns="45700">
-            <a:spAutoFit/>
-          </a:bodyPr>
-          <a:lstStyle/>
-          <a:p>
-            <a:pPr indent="-342900" lvl="0" marL="342900" marR="0" rtl="0" algn="just">
-              <a:lnSpc>
-                <a:spcPct val="100000"/>
-              </a:lnSpc>
-              <a:spcBef>
-                <a:spcPts val="0"/>
-              </a:spcBef>
-              <a:spcAft>
-                <a:spcPts val="0"/>
-              </a:spcAft>
-              <a:buClr>
-                <a:srgbClr val="000000"/>
-              </a:buClr>
-              <a:buSzPts val="2800"/>
-              <a:buFont typeface="Arial"/>
-              <a:buChar char="•"/>
-            </a:pPr>
-            <a:r>
-              <a:rPr b="0" i="0" lang="en-US" sz="2800" u="none" cap="none" strike="noStrike">
-                <a:solidFill>
-                  <a:srgbClr val="000000"/>
-                </a:solidFill>
-                <a:latin typeface="Arial"/>
-                <a:ea typeface="Arial"/>
-                <a:cs typeface="Arial"/>
-                <a:sym typeface="Arial"/>
-              </a:rPr>
-              <a:t>Potential impact on the target audience</a:t>
-            </a:r>
-            <a:endParaRPr/>
-          </a:p>
-          <a:p>
-            <a:pPr indent="-342900" lvl="0" marL="342900" marR="0" rtl="0" algn="just">
-              <a:lnSpc>
-                <a:spcPct val="100000"/>
-              </a:lnSpc>
-              <a:spcBef>
-                <a:spcPts val="0"/>
-              </a:spcBef>
-              <a:spcAft>
-                <a:spcPts val="0"/>
-              </a:spcAft>
-              <a:buClr>
-                <a:srgbClr val="000000"/>
-              </a:buClr>
-              <a:buSzPts val="2800"/>
-              <a:buFont typeface="Arial"/>
-              <a:buChar char="•"/>
-            </a:pPr>
-            <a:r>
-              <a:rPr lang="en-US" sz="2800">
-                <a:solidFill>
-                  <a:srgbClr val="000000"/>
-                </a:solidFill>
-                <a:latin typeface="Arial"/>
-                <a:ea typeface="Arial"/>
-                <a:cs typeface="Arial"/>
-                <a:sym typeface="Arial"/>
-              </a:rPr>
-              <a:t>Benefits of the solution (social, economic, environmental, etc.)</a:t>
-            </a:r>
-            <a:endParaRPr/>
-          </a:p>
-        </p:txBody>
-      </p:sp>
-      <p:sp>
-        <p:nvSpPr>
           <p:cNvPr id="139" name="Google Shape;139;p17"/>
           <p:cNvSpPr txBox="1"/>
           <p:nvPr>
@@ -16049,7 +15424,7 @@
               <a:buNone/>
             </a:pPr>
             <a:r>
-              <a:rPr lang="en-US" sz="1800">
+              <a:rPr lang="en-US" sz="1800" b="1">
                 <a:solidFill>
                   <a:schemeClr val="dk1"/>
                 </a:solidFill>
@@ -16058,7 +15433,7 @@
                 <a:cs typeface="Calibri"/>
                 <a:sym typeface="Calibri"/>
               </a:rPr>
-              <a:t>Your Team Name</a:t>
+              <a:t>AEGIS-TRACE</a:t>
             </a:r>
             <a:endParaRPr sz="1800">
               <a:solidFill>
@@ -16097,6 +15472,30 @@
           <a:ln>
             <a:noFill/>
           </a:ln>
+        </p:spPr>
+      </p:pic>
+      <p:pic>
+        <p:nvPicPr>
+          <p:cNvPr id="143" name="Picture 142" descr="slide_5_impact_profitability.png"/>
+          <p:cNvPicPr>
+            <a:picLocks noChangeAspect="1"/>
+          </p:cNvPicPr>
+          <p:nvPr/>
+        </p:nvPicPr>
+        <p:blipFill>
+          <a:blip r:embed="rId4"/>
+          <a:stretch>
+            <a:fillRect/>
+          </a:stretch>
+        </p:blipFill>
+        <p:spPr>
+          <a:xfrm>
+            <a:off x="384048" y="1207008"/>
+            <a:ext cx="11420856" cy="5029200"/>
+          </a:xfrm>
+          <a:prstGeom prst="rect">
+            <a:avLst/>
+          </a:prstGeom>
         </p:spPr>
       </p:pic>
     </p:spTree>
@@ -16241,72 +15640,6 @@
       </p:sp>
       <p:sp>
         <p:nvSpPr>
-          <p:cNvPr id="150" name="Google Shape;150;p18"/>
-          <p:cNvSpPr txBox="1"/>
-          <p:nvPr/>
-        </p:nvSpPr>
-        <p:spPr>
-          <a:xfrm>
-            <a:off x="609600" y="2795263"/>
-            <a:ext cx="9385300" cy="523220"/>
-          </a:xfrm>
-          <a:prstGeom prst="rect">
-            <a:avLst/>
-          </a:prstGeom>
-          <a:noFill/>
-          <a:ln>
-            <a:noFill/>
-          </a:ln>
-        </p:spPr>
-        <p:txBody>
-          <a:bodyPr anchorCtr="0" anchor="t" bIns="45700" lIns="91425" spcFirstLastPara="1" rIns="91425" wrap="square" tIns="45700">
-            <a:spAutoFit/>
-          </a:bodyPr>
-          <a:lstStyle/>
-          <a:p>
-            <a:pPr indent="-342900" lvl="0" marL="342900" marR="0" rtl="0" algn="just">
-              <a:lnSpc>
-                <a:spcPct val="100000"/>
-              </a:lnSpc>
-              <a:spcBef>
-                <a:spcPts val="0"/>
-              </a:spcBef>
-              <a:spcAft>
-                <a:spcPts val="0"/>
-              </a:spcAft>
-              <a:buClr>
-                <a:srgbClr val="000000"/>
-              </a:buClr>
-              <a:buSzPts val="2800"/>
-              <a:buFont typeface="Arial"/>
-              <a:buChar char="•"/>
-            </a:pPr>
-            <a:r>
-              <a:rPr lang="en-US" sz="2800">
-                <a:solidFill>
-                  <a:srgbClr val="000000"/>
-                </a:solidFill>
-                <a:latin typeface="Arial"/>
-                <a:ea typeface="Arial"/>
-                <a:cs typeface="Arial"/>
-                <a:sym typeface="Arial"/>
-              </a:rPr>
-              <a:t>Details / Links of the reference and research work</a:t>
-            </a:r>
-            <a:endParaRPr b="0" i="0" sz="2800" u="none" cap="none" strike="noStrike">
-              <a:solidFill>
-                <a:srgbClr val="000000"/>
-              </a:solidFill>
-              <a:latin typeface="Arial"/>
-              <a:ea typeface="Arial"/>
-              <a:cs typeface="Arial"/>
-              <a:sym typeface="Arial"/>
-            </a:endParaRPr>
-          </a:p>
-        </p:txBody>
-      </p:sp>
-      <p:sp>
-        <p:nvSpPr>
           <p:cNvPr id="151" name="Google Shape;151;p18"/>
           <p:cNvSpPr txBox="1"/>
           <p:nvPr>
@@ -16484,7 +15817,7 @@
               <a:buNone/>
             </a:pPr>
             <a:r>
-              <a:rPr lang="en-US" sz="1800">
+              <a:rPr lang="en-US" sz="1800" b="1">
                 <a:solidFill>
                   <a:schemeClr val="dk1"/>
                 </a:solidFill>
@@ -16493,7 +15826,7 @@
                 <a:cs typeface="Calibri"/>
                 <a:sym typeface="Calibri"/>
               </a:rPr>
-              <a:t>Your Team Name</a:t>
+              <a:t>AEGIS-TRACE</a:t>
             </a:r>
             <a:endParaRPr sz="1800">
               <a:solidFill>
@@ -16534,884 +15867,28 @@
           </a:ln>
         </p:spPr>
       </p:pic>
-    </p:spTree>
-  </p:cSld>
-  <p:clrMapOvr>
-    <a:masterClrMapping/>
-  </p:clrMapOvr>
-</p:sld>
-</file>
-
-<file path=ppt/slides/slide7.xml><?xml version="1.0" encoding="utf-8"?>
-<p:sld xmlns:a="http://schemas.openxmlformats.org/drawingml/2006/main" xmlns:r="http://schemas.openxmlformats.org/officeDocument/2006/relationships" xmlns:mc="http://schemas.openxmlformats.org/markup-compatibility/2006" xmlns:mv="urn:schemas-microsoft-com:mac:vml" xmlns:p="http://schemas.openxmlformats.org/presentationml/2006/main" xmlns:c="http://schemas.openxmlformats.org/drawingml/2006/chart" xmlns:dgm="http://schemas.openxmlformats.org/drawingml/2006/diagram" xmlns:o="urn:schemas-microsoft-com:office:office" xmlns:v="urn:schemas-microsoft-com:vml" xmlns:pvml="urn:schemas-microsoft-com:office:powerpoint" xmlns:com="http://schemas.openxmlformats.org/drawingml/2006/compatibility" xmlns:p14="http://schemas.microsoft.com/office/powerpoint/2010/main" xmlns:p15="http://schemas.microsoft.com/office/powerpoint/2012/main" xmlns:ahyp="http://schemas.microsoft.com/office/drawing/2018/hyperlinkcolor">
-  <p:cSld>
-    <p:spTree>
-      <p:nvGrpSpPr>
-        <p:cNvPr id="159" name="Shape 159"/>
-        <p:cNvGrpSpPr/>
-        <p:nvPr/>
-      </p:nvGrpSpPr>
-      <p:grpSpPr>
-        <a:xfrm>
-          <a:off x="0" y="0"/>
-          <a:ext cx="0" cy="0"/>
-          <a:chOff x="0" y="0"/>
-          <a:chExt cx="0" cy="0"/>
-        </a:xfrm>
-      </p:grpSpPr>
-      <p:sp>
-        <p:nvSpPr>
-          <p:cNvPr id="160" name="Google Shape;160;p19"/>
-          <p:cNvSpPr/>
+      <p:pic>
+        <p:nvPicPr>
+          <p:cNvPr id="155" name="Picture 154" descr="slide_6_research_references.png"/>
+          <p:cNvPicPr>
+            <a:picLocks noChangeAspect="1"/>
+          </p:cNvPicPr>
           <p:nvPr/>
-        </p:nvSpPr>
+        </p:nvPicPr>
+        <p:blipFill>
+          <a:blip r:embed="rId4"/>
+          <a:stretch>
+            <a:fillRect/>
+          </a:stretch>
+        </p:blipFill>
         <p:spPr>
           <a:xfrm>
-            <a:off x="0" y="6354762"/>
-            <a:ext cx="12191999" cy="503238"/>
+            <a:off x="384048" y="1207008"/>
+            <a:ext cx="11420856" cy="5029200"/>
           </a:xfrm>
           <a:prstGeom prst="rect">
             <a:avLst/>
           </a:prstGeom>
-          <a:solidFill>
-            <a:srgbClr val="0070C0"/>
-          </a:solidFill>
-          <a:ln>
-            <a:noFill/>
-          </a:ln>
-          <a:effectLst>
-            <a:outerShdw rotWithShape="0" dir="5400000" dist="23000">
-              <a:srgbClr val="808080">
-                <a:alpha val="34902"/>
-              </a:srgbClr>
-            </a:outerShdw>
-          </a:effectLst>
-        </p:spPr>
-        <p:txBody>
-          <a:bodyPr anchorCtr="0" anchor="ctr" bIns="45700" lIns="91425" spcFirstLastPara="1" rIns="91425" wrap="square" tIns="45700">
-            <a:noAutofit/>
-          </a:bodyPr>
-          <a:lstStyle/>
-          <a:p>
-            <a:pPr indent="0" lvl="0" marL="0" marR="0" rtl="0" algn="ctr">
-              <a:lnSpc>
-                <a:spcPct val="100000"/>
-              </a:lnSpc>
-              <a:spcBef>
-                <a:spcPts val="0"/>
-              </a:spcBef>
-              <a:spcAft>
-                <a:spcPts val="0"/>
-              </a:spcAft>
-              <a:buClr>
-                <a:schemeClr val="dk1"/>
-              </a:buClr>
-              <a:buSzPts val="1800"/>
-              <a:buFont typeface="Calibri"/>
-              <a:buNone/>
-            </a:pPr>
-            <a:r>
-              <a:t/>
-            </a:r>
-            <a:endParaRPr b="0" i="0" sz="1800" u="none" cap="none" strike="noStrike">
-              <a:solidFill>
-                <a:srgbClr val="953734"/>
-              </a:solidFill>
-              <a:latin typeface="Calibri"/>
-              <a:ea typeface="Calibri"/>
-              <a:cs typeface="Calibri"/>
-              <a:sym typeface="Calibri"/>
-            </a:endParaRPr>
-          </a:p>
-        </p:txBody>
-      </p:sp>
-      <p:sp>
-        <p:nvSpPr>
-          <p:cNvPr id="161" name="Google Shape;161;p19"/>
-          <p:cNvSpPr txBox="1"/>
-          <p:nvPr>
-            <p:ph idx="12" type="sldNum"/>
-          </p:nvPr>
-        </p:nvSpPr>
-        <p:spPr>
-          <a:xfrm>
-            <a:off x="8737600" y="6356353"/>
-            <a:ext cx="2844800" cy="365125"/>
-          </a:xfrm>
-          <a:prstGeom prst="rect">
-            <a:avLst/>
-          </a:prstGeom>
-          <a:noFill/>
-          <a:ln>
-            <a:noFill/>
-          </a:ln>
-        </p:spPr>
-        <p:txBody>
-          <a:bodyPr anchorCtr="0" anchor="ctr" bIns="45700" lIns="91425" spcFirstLastPara="1" rIns="91425" wrap="square" tIns="45700">
-            <a:noAutofit/>
-          </a:bodyPr>
-          <a:lstStyle/>
-          <a:p>
-            <a:pPr indent="0" lvl="0" marL="0" marR="0" rtl="0" algn="r">
-              <a:lnSpc>
-                <a:spcPct val="100000"/>
-              </a:lnSpc>
-              <a:spcBef>
-                <a:spcPts val="0"/>
-              </a:spcBef>
-              <a:spcAft>
-                <a:spcPts val="0"/>
-              </a:spcAft>
-              <a:buClr>
-                <a:srgbClr val="FFFFFF"/>
-              </a:buClr>
-              <a:buSzPts val="1200"/>
-              <a:buFont typeface="Oswald"/>
-              <a:buNone/>
-            </a:pPr>
-            <a:fld id="{00000000-1234-1234-1234-123412341234}" type="slidenum">
-              <a:rPr b="1" i="0" lang="en-US" sz="1200" u="none" cap="none" strike="noStrike">
-                <a:solidFill>
-                  <a:srgbClr val="FFFFFF"/>
-                </a:solidFill>
-                <a:latin typeface="Oswald"/>
-                <a:ea typeface="Oswald"/>
-                <a:cs typeface="Oswald"/>
-                <a:sym typeface="Oswald"/>
-              </a:rPr>
-              <a:t>‹#›</a:t>
-            </a:fld>
-            <a:endParaRPr b="1" i="0" sz="1200" u="none" cap="none" strike="noStrike">
-              <a:solidFill>
-                <a:srgbClr val="FFFFFF"/>
-              </a:solidFill>
-              <a:latin typeface="Oswald"/>
-              <a:ea typeface="Oswald"/>
-              <a:cs typeface="Oswald"/>
-              <a:sym typeface="Oswald"/>
-            </a:endParaRPr>
-          </a:p>
-        </p:txBody>
-      </p:sp>
-      <p:sp>
-        <p:nvSpPr>
-          <p:cNvPr id="162" name="Google Shape;162;p19"/>
-          <p:cNvSpPr txBox="1"/>
-          <p:nvPr>
-            <p:ph idx="11" type="ftr"/>
-          </p:nvPr>
-        </p:nvSpPr>
-        <p:spPr>
-          <a:xfrm>
-            <a:off x="4648200" y="6356353"/>
-            <a:ext cx="3204000" cy="365125"/>
-          </a:xfrm>
-          <a:prstGeom prst="rect">
-            <a:avLst/>
-          </a:prstGeom>
-          <a:noFill/>
-          <a:ln>
-            <a:noFill/>
-          </a:ln>
-        </p:spPr>
-        <p:txBody>
-          <a:bodyPr anchorCtr="0" anchor="ctr" bIns="45700" lIns="91425" spcFirstLastPara="1" rIns="91425" wrap="square" tIns="45700">
-            <a:noAutofit/>
-          </a:bodyPr>
-          <a:lstStyle/>
-          <a:p>
-            <a:pPr indent="0" lvl="0" marL="0" marR="0" rtl="0" algn="ctr">
-              <a:lnSpc>
-                <a:spcPct val="100000"/>
-              </a:lnSpc>
-              <a:spcBef>
-                <a:spcPts val="0"/>
-              </a:spcBef>
-              <a:spcAft>
-                <a:spcPts val="0"/>
-              </a:spcAft>
-              <a:buClr>
-                <a:srgbClr val="FFFFFF"/>
-              </a:buClr>
-              <a:buSzPts val="1200"/>
-              <a:buFont typeface="Oswald"/>
-              <a:buNone/>
-            </a:pPr>
-            <a:r>
-              <a:rPr b="0" i="0" lang="en-US" sz="1200" u="none" cap="none" strike="noStrike">
-                <a:solidFill>
-                  <a:srgbClr val="FFFFFF"/>
-                </a:solidFill>
-                <a:latin typeface="Oswald"/>
-                <a:ea typeface="Oswald"/>
-                <a:cs typeface="Oswald"/>
-                <a:sym typeface="Oswald"/>
-              </a:rPr>
-              <a:t>@SIH Idea submission- Template</a:t>
-            </a:r>
-            <a:endParaRPr b="0" i="0" sz="1200" u="none" cap="none" strike="noStrike">
-              <a:solidFill>
-                <a:srgbClr val="FFFFFF"/>
-              </a:solidFill>
-              <a:latin typeface="Oswald"/>
-              <a:ea typeface="Oswald"/>
-              <a:cs typeface="Oswald"/>
-              <a:sym typeface="Oswald"/>
-            </a:endParaRPr>
-          </a:p>
-        </p:txBody>
-      </p:sp>
-      <p:sp>
-        <p:nvSpPr>
-          <p:cNvPr id="163" name="Google Shape;163;p19"/>
-          <p:cNvSpPr/>
-          <p:nvPr/>
-        </p:nvSpPr>
-        <p:spPr>
-          <a:xfrm>
-            <a:off x="0" y="1791032"/>
-            <a:ext cx="12192000" cy="4319200"/>
-          </a:xfrm>
-          <a:prstGeom prst="round2DiagRect">
-            <a:avLst>
-              <a:gd fmla="val 16667" name="adj1"/>
-              <a:gd fmla="val 0" name="adj2"/>
-            </a:avLst>
-          </a:prstGeom>
-          <a:solidFill>
-            <a:srgbClr val="DAE5F1"/>
-          </a:solidFill>
-          <a:ln cap="flat" cmpd="sng" w="38100">
-            <a:solidFill>
-              <a:srgbClr val="4A7DBA"/>
-            </a:solidFill>
-            <a:prstDash val="solid"/>
-            <a:round/>
-            <a:headEnd len="sm" w="sm" type="none"/>
-            <a:tailEnd len="sm" w="sm" type="none"/>
-          </a:ln>
-          <a:effectLst>
-            <a:outerShdw blurRad="40000" rotWithShape="0" dir="5400000" dist="23000">
-              <a:srgbClr val="000000">
-                <a:alpha val="34902"/>
-              </a:srgbClr>
-            </a:outerShdw>
-          </a:effectLst>
-        </p:spPr>
-        <p:txBody>
-          <a:bodyPr anchorCtr="0" anchor="ctr" bIns="45700" lIns="91425" spcFirstLastPara="1" rIns="91425" wrap="square" tIns="45700">
-            <a:noAutofit/>
-          </a:bodyPr>
-          <a:lstStyle/>
-          <a:p>
-            <a:pPr indent="0" lvl="0" marL="0" marR="0" rtl="0" algn="ctr">
-              <a:spcBef>
-                <a:spcPts val="0"/>
-              </a:spcBef>
-              <a:spcAft>
-                <a:spcPts val="0"/>
-              </a:spcAft>
-              <a:buNone/>
-            </a:pPr>
-            <a:r>
-              <a:t/>
-            </a:r>
-            <a:endParaRPr sz="1800">
-              <a:solidFill>
-                <a:schemeClr val="lt1"/>
-              </a:solidFill>
-              <a:latin typeface="Calibri"/>
-              <a:ea typeface="Calibri"/>
-              <a:cs typeface="Calibri"/>
-              <a:sym typeface="Calibri"/>
-            </a:endParaRPr>
-          </a:p>
-        </p:txBody>
-      </p:sp>
-      <p:sp>
-        <p:nvSpPr>
-          <p:cNvPr id="164" name="Google Shape;164;p19"/>
-          <p:cNvSpPr txBox="1"/>
-          <p:nvPr/>
-        </p:nvSpPr>
-        <p:spPr>
-          <a:xfrm>
-            <a:off x="367832" y="1915454"/>
-            <a:ext cx="11764736" cy="4070356"/>
-          </a:xfrm>
-          <a:prstGeom prst="rect">
-            <a:avLst/>
-          </a:prstGeom>
-          <a:noFill/>
-          <a:ln>
-            <a:noFill/>
-          </a:ln>
-        </p:spPr>
-        <p:txBody>
-          <a:bodyPr anchorCtr="0" anchor="t" bIns="45700" lIns="91425" spcFirstLastPara="1" rIns="91425" wrap="square" tIns="45700">
-            <a:noAutofit/>
-          </a:bodyPr>
-          <a:lstStyle/>
-          <a:p>
-            <a:pPr indent="-514350" lvl="0" marL="514350" marR="0" rtl="0" algn="just">
-              <a:lnSpc>
-                <a:spcPct val="90000"/>
-              </a:lnSpc>
-              <a:spcBef>
-                <a:spcPts val="0"/>
-              </a:spcBef>
-              <a:spcAft>
-                <a:spcPts val="0"/>
-              </a:spcAft>
-              <a:buClr>
-                <a:schemeClr val="dk1"/>
-              </a:buClr>
-              <a:buSzPts val="1800"/>
-              <a:buFont typeface="Calibri"/>
-              <a:buAutoNum type="arabicPeriod"/>
-            </a:pPr>
-            <a:r>
-              <a:rPr b="1" i="0" lang="en-US" sz="1800" u="none" cap="none" strike="noStrike">
-                <a:solidFill>
-                  <a:schemeClr val="dk1"/>
-                </a:solidFill>
-                <a:latin typeface="Arial"/>
-                <a:ea typeface="Arial"/>
-                <a:cs typeface="Arial"/>
-                <a:sym typeface="Arial"/>
-              </a:rPr>
-              <a:t>Kindly keep the maximum slides limit up to six </a:t>
-            </a:r>
-            <a:r>
-              <a:rPr b="1" i="0" lang="en-US" sz="1800" u="none" cap="none" strike="noStrike">
-                <a:solidFill>
-                  <a:srgbClr val="C00000"/>
-                </a:solidFill>
-                <a:latin typeface="Arial"/>
-                <a:ea typeface="Arial"/>
-                <a:cs typeface="Arial"/>
-                <a:sym typeface="Arial"/>
-              </a:rPr>
-              <a:t>(6). </a:t>
-            </a:r>
-            <a:r>
-              <a:rPr b="1" i="0" lang="en-US" sz="1800" u="none" cap="none" strike="noStrike">
-                <a:solidFill>
-                  <a:schemeClr val="dk1"/>
-                </a:solidFill>
-                <a:latin typeface="Arial"/>
-                <a:ea typeface="Arial"/>
-                <a:cs typeface="Arial"/>
-                <a:sym typeface="Arial"/>
-              </a:rPr>
-              <a:t>( Including the title slide) </a:t>
-            </a:r>
-            <a:endParaRPr b="1" sz="1800">
-              <a:solidFill>
-                <a:schemeClr val="dk1"/>
-              </a:solidFill>
-              <a:latin typeface="Arial"/>
-              <a:ea typeface="Arial"/>
-              <a:cs typeface="Arial"/>
-              <a:sym typeface="Arial"/>
-            </a:endParaRPr>
-          </a:p>
-          <a:p>
-            <a:pPr indent="-514350" lvl="0" marL="514350" marR="0" rtl="0" algn="just">
-              <a:lnSpc>
-                <a:spcPct val="90000"/>
-              </a:lnSpc>
-              <a:spcBef>
-                <a:spcPts val="1000"/>
-              </a:spcBef>
-              <a:spcAft>
-                <a:spcPts val="0"/>
-              </a:spcAft>
-              <a:buClr>
-                <a:schemeClr val="dk1"/>
-              </a:buClr>
-              <a:buSzPts val="1800"/>
-              <a:buFont typeface="Calibri"/>
-              <a:buAutoNum type="arabicPeriod"/>
-            </a:pPr>
-            <a:r>
-              <a:rPr b="1" i="0" lang="en-US" sz="1800" u="none" cap="none" strike="noStrike">
-                <a:solidFill>
-                  <a:schemeClr val="dk1"/>
-                </a:solidFill>
-                <a:latin typeface="Arial"/>
-                <a:ea typeface="Arial"/>
-                <a:cs typeface="Arial"/>
-                <a:sym typeface="Arial"/>
-              </a:rPr>
-              <a:t>Try to avoid paragraphs and post your idea in points /diagrams / Infographics /pictures </a:t>
-            </a:r>
-            <a:endParaRPr b="1" sz="1800">
-              <a:solidFill>
-                <a:schemeClr val="dk1"/>
-              </a:solidFill>
-              <a:latin typeface="Arial"/>
-              <a:ea typeface="Arial"/>
-              <a:cs typeface="Arial"/>
-              <a:sym typeface="Arial"/>
-            </a:endParaRPr>
-          </a:p>
-          <a:p>
-            <a:pPr indent="-514350" lvl="0" marL="514350" marR="0" rtl="0" algn="just">
-              <a:lnSpc>
-                <a:spcPct val="90000"/>
-              </a:lnSpc>
-              <a:spcBef>
-                <a:spcPts val="1000"/>
-              </a:spcBef>
-              <a:spcAft>
-                <a:spcPts val="0"/>
-              </a:spcAft>
-              <a:buClr>
-                <a:schemeClr val="dk1"/>
-              </a:buClr>
-              <a:buSzPts val="1800"/>
-              <a:buFont typeface="Calibri"/>
-              <a:buAutoNum type="arabicPeriod"/>
-            </a:pPr>
-            <a:r>
-              <a:rPr b="1" i="0" lang="en-US" sz="1800" u="none" cap="none" strike="noStrike">
-                <a:solidFill>
-                  <a:schemeClr val="dk1"/>
-                </a:solidFill>
-                <a:latin typeface="Arial"/>
-                <a:ea typeface="Arial"/>
-                <a:cs typeface="Arial"/>
-                <a:sym typeface="Arial"/>
-              </a:rPr>
-              <a:t>Keep your explanation precise and easy to understand</a:t>
-            </a:r>
-            <a:endParaRPr b="1" sz="1800">
-              <a:solidFill>
-                <a:schemeClr val="dk1"/>
-              </a:solidFill>
-              <a:latin typeface="Arial"/>
-              <a:ea typeface="Arial"/>
-              <a:cs typeface="Arial"/>
-              <a:sym typeface="Arial"/>
-            </a:endParaRPr>
-          </a:p>
-          <a:p>
-            <a:pPr indent="-514350" lvl="0" marL="514350" marR="0" rtl="0" algn="just">
-              <a:lnSpc>
-                <a:spcPct val="90000"/>
-              </a:lnSpc>
-              <a:spcBef>
-                <a:spcPts val="1000"/>
-              </a:spcBef>
-              <a:spcAft>
-                <a:spcPts val="0"/>
-              </a:spcAft>
-              <a:buClr>
-                <a:schemeClr val="dk1"/>
-              </a:buClr>
-              <a:buSzPts val="1800"/>
-              <a:buFont typeface="Calibri"/>
-              <a:buAutoNum type="arabicPeriod"/>
-            </a:pPr>
-            <a:r>
-              <a:rPr b="1" i="0" lang="en-US" sz="1800" u="none" cap="none" strike="noStrike">
-                <a:solidFill>
-                  <a:schemeClr val="dk1"/>
-                </a:solidFill>
-                <a:latin typeface="Arial"/>
-                <a:ea typeface="Arial"/>
-                <a:cs typeface="Arial"/>
-                <a:sym typeface="Arial"/>
-              </a:rPr>
-              <a:t>Idea should be unique and novel. </a:t>
-            </a:r>
-            <a:endParaRPr b="1" sz="1800">
-              <a:solidFill>
-                <a:schemeClr val="dk1"/>
-              </a:solidFill>
-              <a:latin typeface="Arial"/>
-              <a:ea typeface="Arial"/>
-              <a:cs typeface="Arial"/>
-              <a:sym typeface="Arial"/>
-            </a:endParaRPr>
-          </a:p>
-          <a:p>
-            <a:pPr indent="-514350" lvl="0" marL="514350" marR="0" rtl="0" algn="just">
-              <a:lnSpc>
-                <a:spcPct val="90000"/>
-              </a:lnSpc>
-              <a:spcBef>
-                <a:spcPts val="1000"/>
-              </a:spcBef>
-              <a:spcAft>
-                <a:spcPts val="0"/>
-              </a:spcAft>
-              <a:buClr>
-                <a:schemeClr val="dk1"/>
-              </a:buClr>
-              <a:buSzPts val="1800"/>
-              <a:buFont typeface="Calibri"/>
-              <a:buAutoNum type="arabicPeriod"/>
-            </a:pPr>
-            <a:r>
-              <a:rPr b="1" i="0" lang="en-US" sz="1800" u="none" cap="none" strike="noStrike">
-                <a:solidFill>
-                  <a:schemeClr val="dk1"/>
-                </a:solidFill>
-                <a:latin typeface="Arial"/>
-                <a:ea typeface="Arial"/>
-                <a:cs typeface="Arial"/>
-                <a:sym typeface="Arial"/>
-              </a:rPr>
-              <a:t>You can only use provided </a:t>
-            </a:r>
-            <a:r>
-              <a:rPr b="1" lang="en-US" sz="1800">
-                <a:solidFill>
-                  <a:schemeClr val="dk1"/>
-                </a:solidFill>
-                <a:latin typeface="Arial"/>
-                <a:ea typeface="Arial"/>
-                <a:cs typeface="Arial"/>
-                <a:sym typeface="Arial"/>
-              </a:rPr>
-              <a:t>template</a:t>
-            </a:r>
-            <a:r>
-              <a:rPr b="1" i="0" lang="en-US" sz="1800" u="none" cap="none" strike="noStrike">
-                <a:solidFill>
-                  <a:schemeClr val="dk1"/>
-                </a:solidFill>
-                <a:latin typeface="Arial"/>
-                <a:ea typeface="Arial"/>
-                <a:cs typeface="Arial"/>
-                <a:sym typeface="Arial"/>
-              </a:rPr>
-              <a:t> for making the </a:t>
-            </a:r>
-            <a:r>
-              <a:rPr b="1" lang="en-US" sz="1800">
-                <a:solidFill>
-                  <a:schemeClr val="dk1"/>
-                </a:solidFill>
-                <a:latin typeface="Arial"/>
-                <a:ea typeface="Arial"/>
-                <a:cs typeface="Arial"/>
-                <a:sym typeface="Arial"/>
-              </a:rPr>
-              <a:t>PPT</a:t>
-            </a:r>
-            <a:r>
-              <a:rPr b="1" i="0" lang="en-US" sz="1800" u="none" cap="none" strike="noStrike">
-                <a:solidFill>
-                  <a:schemeClr val="dk1"/>
-                </a:solidFill>
-                <a:latin typeface="Arial"/>
-                <a:ea typeface="Arial"/>
-                <a:cs typeface="Arial"/>
-                <a:sym typeface="Arial"/>
-              </a:rPr>
-              <a:t> without changing the idea details pointers (mentioned in previous slides).</a:t>
-            </a:r>
-            <a:endParaRPr b="1" i="0" sz="1800" u="none" cap="none" strike="noStrike">
-              <a:solidFill>
-                <a:schemeClr val="dk1"/>
-              </a:solidFill>
-              <a:latin typeface="Arial"/>
-              <a:ea typeface="Arial"/>
-              <a:cs typeface="Arial"/>
-              <a:sym typeface="Arial"/>
-            </a:endParaRPr>
-          </a:p>
-          <a:p>
-            <a:pPr indent="-514350" lvl="0" marL="514350" marR="0" rtl="0" algn="just">
-              <a:lnSpc>
-                <a:spcPct val="90000"/>
-              </a:lnSpc>
-              <a:spcBef>
-                <a:spcPts val="1000"/>
-              </a:spcBef>
-              <a:spcAft>
-                <a:spcPts val="0"/>
-              </a:spcAft>
-              <a:buClr>
-                <a:schemeClr val="dk1"/>
-              </a:buClr>
-              <a:buSzPts val="1800"/>
-              <a:buFont typeface="Calibri"/>
-              <a:buAutoNum type="arabicPeriod"/>
-            </a:pPr>
-            <a:r>
-              <a:rPr b="1" i="0" lang="en-US" sz="1800" u="none" cap="none" strike="noStrike">
-                <a:solidFill>
-                  <a:schemeClr val="dk1"/>
-                </a:solidFill>
-                <a:latin typeface="Arial"/>
-                <a:ea typeface="Arial"/>
-                <a:cs typeface="Arial"/>
-                <a:sym typeface="Arial"/>
-              </a:rPr>
-              <a:t>You need to save the file in PDF and upload the same on portal. No PPT, Word Doc or any other format will be supported.</a:t>
-            </a:r>
-            <a:endParaRPr b="1" sz="1800">
-              <a:solidFill>
-                <a:schemeClr val="dk1"/>
-              </a:solidFill>
-              <a:latin typeface="Arial"/>
-              <a:ea typeface="Arial"/>
-              <a:cs typeface="Arial"/>
-              <a:sym typeface="Arial"/>
-            </a:endParaRPr>
-          </a:p>
-          <a:p>
-            <a:pPr indent="-349885" lvl="0" marL="514350" marR="0" rtl="0" algn="just">
-              <a:lnSpc>
-                <a:spcPct val="90000"/>
-              </a:lnSpc>
-              <a:spcBef>
-                <a:spcPts val="1000"/>
-              </a:spcBef>
-              <a:spcAft>
-                <a:spcPts val="0"/>
-              </a:spcAft>
-              <a:buClr>
-                <a:schemeClr val="dk1"/>
-              </a:buClr>
-              <a:buSzPts val="1800"/>
-              <a:buFont typeface="Calibri"/>
-              <a:buNone/>
-            </a:pPr>
-            <a:r>
-              <a:t/>
-            </a:r>
-            <a:endParaRPr b="1" i="0" sz="1800" u="none" cap="none" strike="noStrike">
-              <a:solidFill>
-                <a:schemeClr val="dk1"/>
-              </a:solidFill>
-              <a:latin typeface="Arial"/>
-              <a:ea typeface="Arial"/>
-              <a:cs typeface="Arial"/>
-              <a:sym typeface="Arial"/>
-            </a:endParaRPr>
-          </a:p>
-          <a:p>
-            <a:pPr indent="0" lvl="0" marL="0" marR="0" rtl="0" algn="just">
-              <a:lnSpc>
-                <a:spcPct val="90000"/>
-              </a:lnSpc>
-              <a:spcBef>
-                <a:spcPts val="1000"/>
-              </a:spcBef>
-              <a:spcAft>
-                <a:spcPts val="0"/>
-              </a:spcAft>
-              <a:buClr>
-                <a:schemeClr val="dk1"/>
-              </a:buClr>
-              <a:buSzPts val="1800"/>
-              <a:buFont typeface="Arial"/>
-              <a:buNone/>
-            </a:pPr>
-            <a:r>
-              <a:rPr b="1" i="0" lang="en-US" sz="1800" u="none" cap="none" strike="noStrike">
-                <a:solidFill>
-                  <a:srgbClr val="C00000"/>
-                </a:solidFill>
-                <a:latin typeface="Arial"/>
-                <a:ea typeface="Arial"/>
-                <a:cs typeface="Arial"/>
-                <a:sym typeface="Arial"/>
-              </a:rPr>
-              <a:t>Note - You can delete this slide (Important Pointers) when you upload the details of your idea on SIH portal.</a:t>
-            </a:r>
-            <a:endParaRPr b="1" sz="1800">
-              <a:solidFill>
-                <a:srgbClr val="C00000"/>
-              </a:solidFill>
-              <a:latin typeface="Arial"/>
-              <a:ea typeface="Arial"/>
-              <a:cs typeface="Arial"/>
-              <a:sym typeface="Arial"/>
-            </a:endParaRPr>
-          </a:p>
-          <a:p>
-            <a:pPr indent="-316230" lvl="1" marL="914400" marR="0" rtl="0" algn="just">
-              <a:lnSpc>
-                <a:spcPct val="90000"/>
-              </a:lnSpc>
-              <a:spcBef>
-                <a:spcPts val="500"/>
-              </a:spcBef>
-              <a:spcAft>
-                <a:spcPts val="0"/>
-              </a:spcAft>
-              <a:buClr>
-                <a:schemeClr val="dk1"/>
-              </a:buClr>
-              <a:buSzPts val="2000"/>
-              <a:buFont typeface="Calibri"/>
-              <a:buNone/>
-            </a:pPr>
-            <a:r>
-              <a:t/>
-            </a:r>
-            <a:endParaRPr b="1" i="0" sz="2000" u="none" cap="none" strike="noStrike">
-              <a:solidFill>
-                <a:schemeClr val="dk1"/>
-              </a:solidFill>
-              <a:latin typeface="Arial"/>
-              <a:ea typeface="Arial"/>
-              <a:cs typeface="Arial"/>
-              <a:sym typeface="Arial"/>
-            </a:endParaRPr>
-          </a:p>
-        </p:txBody>
-      </p:sp>
-      <p:sp>
-        <p:nvSpPr>
-          <p:cNvPr id="165" name="Google Shape;165;p19"/>
-          <p:cNvSpPr txBox="1"/>
-          <p:nvPr/>
-        </p:nvSpPr>
-        <p:spPr>
-          <a:xfrm>
-            <a:off x="1393371" y="107066"/>
-            <a:ext cx="8410540" cy="646331"/>
-          </a:xfrm>
-          <a:prstGeom prst="rect">
-            <a:avLst/>
-          </a:prstGeom>
-          <a:noFill/>
-          <a:ln>
-            <a:noFill/>
-          </a:ln>
-        </p:spPr>
-        <p:txBody>
-          <a:bodyPr anchorCtr="0" anchor="t" bIns="45700" lIns="91425" spcFirstLastPara="1" rIns="91425" wrap="square" tIns="45700">
-            <a:spAutoFit/>
-          </a:bodyPr>
-          <a:lstStyle/>
-          <a:p>
-            <a:pPr indent="0" lvl="0" marL="0" marR="0" rtl="0" algn="ctr">
-              <a:spcBef>
-                <a:spcPts val="0"/>
-              </a:spcBef>
-              <a:spcAft>
-                <a:spcPts val="0"/>
-              </a:spcAft>
-              <a:buNone/>
-            </a:pPr>
-            <a:r>
-              <a:rPr b="1" lang="en-US" sz="3600">
-                <a:solidFill>
-                  <a:schemeClr val="dk1"/>
-                </a:solidFill>
-                <a:latin typeface="Times New Roman"/>
-                <a:ea typeface="Times New Roman"/>
-                <a:cs typeface="Times New Roman"/>
-                <a:sym typeface="Times New Roman"/>
-              </a:rPr>
-              <a:t>IMPORTANT INSTRUCTIONS</a:t>
-            </a:r>
-            <a:endParaRPr b="1" sz="3600">
-              <a:solidFill>
-                <a:schemeClr val="dk1"/>
-              </a:solidFill>
-              <a:latin typeface="Times New Roman"/>
-              <a:ea typeface="Times New Roman"/>
-              <a:cs typeface="Times New Roman"/>
-              <a:sym typeface="Times New Roman"/>
-            </a:endParaRPr>
-          </a:p>
-        </p:txBody>
-      </p:sp>
-      <p:sp>
-        <p:nvSpPr>
-          <p:cNvPr id="166" name="Google Shape;166;p19"/>
-          <p:cNvSpPr txBox="1"/>
-          <p:nvPr/>
-        </p:nvSpPr>
-        <p:spPr>
-          <a:xfrm>
-            <a:off x="602343" y="1181900"/>
-            <a:ext cx="9557657" cy="341632"/>
-          </a:xfrm>
-          <a:prstGeom prst="rect">
-            <a:avLst/>
-          </a:prstGeom>
-          <a:noFill/>
-          <a:ln>
-            <a:noFill/>
-          </a:ln>
-        </p:spPr>
-        <p:txBody>
-          <a:bodyPr anchorCtr="0" anchor="t" bIns="45700" lIns="91425" spcFirstLastPara="1" rIns="91425" wrap="square" tIns="45700">
-            <a:spAutoFit/>
-          </a:bodyPr>
-          <a:lstStyle/>
-          <a:p>
-            <a:pPr indent="0" lvl="0" marL="0" marR="0" rtl="0" algn="just">
-              <a:lnSpc>
-                <a:spcPct val="90000"/>
-              </a:lnSpc>
-              <a:spcBef>
-                <a:spcPts val="0"/>
-              </a:spcBef>
-              <a:spcAft>
-                <a:spcPts val="0"/>
-              </a:spcAft>
-              <a:buNone/>
-            </a:pPr>
-            <a:r>
-              <a:rPr b="1" lang="en-US" sz="1800">
-                <a:solidFill>
-                  <a:schemeClr val="dk1"/>
-                </a:solidFill>
-                <a:latin typeface="Arial"/>
-                <a:ea typeface="Arial"/>
-                <a:cs typeface="Arial"/>
-                <a:sym typeface="Arial"/>
-              </a:rPr>
-              <a:t>Please ensure below pointers are met while submitting the Idea PPT:</a:t>
-            </a:r>
-            <a:endParaRPr b="1" sz="1800">
-              <a:solidFill>
-                <a:schemeClr val="dk1"/>
-              </a:solidFill>
-              <a:latin typeface="Arial"/>
-              <a:ea typeface="Arial"/>
-              <a:cs typeface="Arial"/>
-              <a:sym typeface="Arial"/>
-            </a:endParaRPr>
-          </a:p>
-        </p:txBody>
-      </p:sp>
-      <p:pic>
-        <p:nvPicPr>
-          <p:cNvPr id="167" name="Google Shape;167;p19"/>
-          <p:cNvPicPr preferRelativeResize="0"/>
-          <p:nvPr/>
-        </p:nvPicPr>
-        <p:blipFill rotWithShape="1">
-          <a:blip r:embed="rId3">
-            <a:alphaModFix/>
-          </a:blip>
-          <a:srcRect b="0" l="0" r="0" t="0"/>
-          <a:stretch/>
-        </p:blipFill>
-        <p:spPr>
-          <a:xfrm>
-            <a:off x="9780086" y="1500"/>
-            <a:ext cx="2249850" cy="1062337"/>
-          </a:xfrm>
-          <a:prstGeom prst="rect">
-            <a:avLst/>
-          </a:prstGeom>
-          <a:noFill/>
-          <a:ln>
-            <a:noFill/>
-          </a:ln>
         </p:spPr>
       </p:pic>
     </p:spTree>

</xml_diff>